<commit_message>
Rebrand worksheets to 個人指導塾PLATZ and add A4 print PDF
Co-Authored-By: Claude Opus 5.5 <noreply@anthropic.com>
Claude-Session: https://claude.ai/code/session_01ETV8E6rMJUMqstoaV1RYSL
</commit_message>
<xml_diff>
--- a/小論文添削（ショー）/ワークシート/サンプル大学_看護学部_小論文ワークシート.pptx
+++ b/小論文添削（ショー）/ワークシート/サンプル大学_看護学部_小論文ワークシート.pptx
@@ -3416,7 +3416,7 @@
                 <a:latin typeface="游ゴシック"/>
                 <a:ea typeface="游ゴシック"/>
               </a:rPr>
-              <a:t>C3進学アカデミー　学習支援資料</a:t>
+              <a:t>個人指導塾PLATZ　学習支援資料</a:t>
             </a:r>
           </a:p>
         </p:txBody>
@@ -3666,7 +3666,7 @@
                 <a:latin typeface="游ゴシック"/>
                 <a:ea typeface="游ゴシック"/>
               </a:rPr>
-              <a:t>C3進学アカデミー　サンプル大学 看護学部 小論文ワークシート</a:t>
+              <a:t>個人指導塾PLATZ　サンプル大学 看護学部 小論文ワークシート</a:t>
             </a:r>
           </a:p>
         </p:txBody>
@@ -4452,7 +4452,7 @@
                 <a:latin typeface="游ゴシック"/>
                 <a:ea typeface="游ゴシック"/>
               </a:rPr>
-              <a:t>C3進学アカデミー　サンプル大学 看護学部 小論文ワークシート</a:t>
+              <a:t>個人指導塾PLATZ　サンプル大学 看護学部 小論文ワークシート</a:t>
             </a:r>
           </a:p>
         </p:txBody>
@@ -5138,7 +5138,7 @@
                 <a:latin typeface="游ゴシック"/>
                 <a:ea typeface="游ゴシック"/>
               </a:rPr>
-              <a:t>C3進学アカデミー　サンプル大学 看護学部 小論文ワークシート</a:t>
+              <a:t>個人指導塾PLATZ　サンプル大学 看護学部 小論文ワークシート</a:t>
             </a:r>
           </a:p>
         </p:txBody>
@@ -6254,7 +6254,7 @@
                 <a:latin typeface="游ゴシック"/>
                 <a:ea typeface="游ゴシック"/>
               </a:rPr>
-              <a:t>C3進学アカデミー　サンプル大学 看護学部 小論文ワークシート</a:t>
+              <a:t>個人指導塾PLATZ　サンプル大学 看護学部 小論文ワークシート</a:t>
             </a:r>
           </a:p>
         </p:txBody>
@@ -7330,7 +7330,7 @@
                 <a:latin typeface="游ゴシック"/>
                 <a:ea typeface="游ゴシック"/>
               </a:rPr>
-              <a:t>C3進学アカデミー　サンプル大学 看護学部 小論文ワークシート</a:t>
+              <a:t>個人指導塾PLATZ　サンプル大学 看護学部 小論文ワークシート</a:t>
             </a:r>
           </a:p>
         </p:txBody>
@@ -8689,7 +8689,7 @@
                 <a:latin typeface="游ゴシック"/>
                 <a:ea typeface="游ゴシック"/>
               </a:rPr>
-              <a:t>C3進学アカデミー　サンプル大学 看護学部 小論文ワークシート</a:t>
+              <a:t>個人指導塾PLATZ　サンプル大学 看護学部 小論文ワークシート</a:t>
             </a:r>
           </a:p>
         </p:txBody>
@@ -10099,7 +10099,7 @@
                 <a:latin typeface="游ゴシック"/>
                 <a:ea typeface="游ゴシック"/>
               </a:rPr>
-              <a:t>C3進学アカデミー　サンプル大学 看護学部 小論文ワークシート</a:t>
+              <a:t>個人指導塾PLATZ　サンプル大学 看護学部 小論文ワークシート</a:t>
             </a:r>
           </a:p>
         </p:txBody>
@@ -10785,7 +10785,7 @@
                 <a:latin typeface="游ゴシック"/>
                 <a:ea typeface="游ゴシック"/>
               </a:rPr>
-              <a:t>C3進学アカデミー　サンプル大学 看護学部 小論文ワークシート</a:t>
+              <a:t>個人指導塾PLATZ　サンプル大学 看護学部 小論文ワークシート</a:t>
             </a:r>
           </a:p>
         </p:txBody>
@@ -11571,7 +11571,7 @@
                 <a:latin typeface="游ゴシック"/>
                 <a:ea typeface="游ゴシック"/>
               </a:rPr>
-              <a:t>C3進学アカデミー　サンプル大学 看護学部 小論文ワークシート</a:t>
+              <a:t>個人指導塾PLATZ　サンプル大学 看護学部 小論文ワークシート</a:t>
             </a:r>
           </a:p>
         </p:txBody>
@@ -12399,7 +12399,7 @@
                 <a:latin typeface="游ゴシック"/>
                 <a:ea typeface="游ゴシック"/>
               </a:rPr>
-              <a:t>C3進学アカデミー　サンプル大学 看護学部 小論文ワークシート</a:t>
+              <a:t>個人指導塾PLATZ　サンプル大学 看護学部 小論文ワークシート</a:t>
             </a:r>
           </a:p>
         </p:txBody>
@@ -13375,7 +13375,7 @@
                 <a:latin typeface="游ゴシック"/>
                 <a:ea typeface="游ゴシック"/>
               </a:rPr>
-              <a:t>C3進学アカデミー　サンプル大学 看護学部 小論文ワークシート</a:t>
+              <a:t>個人指導塾PLATZ　サンプル大学 看護学部 小論文ワークシート</a:t>
             </a:r>
           </a:p>
         </p:txBody>
@@ -14185,7 +14185,7 @@
                 <a:latin typeface="游ゴシック"/>
                 <a:ea typeface="游ゴシック"/>
               </a:rPr>
-              <a:t>C3進学アカデミー　サンプル大学 看護学部 小論文ワークシート</a:t>
+              <a:t>個人指導塾PLATZ　サンプル大学 看護学部 小論文ワークシート</a:t>
             </a:r>
           </a:p>
         </p:txBody>
@@ -15544,7 +15544,7 @@
                 <a:latin typeface="游ゴシック"/>
                 <a:ea typeface="游ゴシック"/>
               </a:rPr>
-              <a:t>C3進学アカデミー　サンプル大学 看護学部 小論文ワークシート</a:t>
+              <a:t>個人指導塾PLATZ　サンプル大学 看護学部 小論文ワークシート</a:t>
             </a:r>
           </a:p>
         </p:txBody>
@@ -16806,7 +16806,7 @@
                 <a:latin typeface="游ゴシック"/>
                 <a:ea typeface="游ゴシック"/>
               </a:rPr>
-              <a:t>C3進学アカデミー　サンプル大学 看護学部 小論文ワークシート</a:t>
+              <a:t>個人指導塾PLATZ　サンプル大学 看護学部 小論文ワークシート</a:t>
             </a:r>
           </a:p>
         </p:txBody>
@@ -17492,7 +17492,7 @@
                 <a:latin typeface="游ゴシック"/>
                 <a:ea typeface="游ゴシック"/>
               </a:rPr>
-              <a:t>C3進学アカデミー　サンプル大学 看護学部 小論文ワークシート</a:t>
+              <a:t>個人指導塾PLATZ　サンプル大学 看護学部 小論文ワークシート</a:t>
             </a:r>
           </a:p>
         </p:txBody>
@@ -18134,7 +18134,7 @@
                 <a:latin typeface="游ゴシック"/>
                 <a:ea typeface="游ゴシック"/>
               </a:rPr>
-              <a:t>C3進学アカデミー　サンプル大学 看護学部 小論文ワークシート</a:t>
+              <a:t>個人指導塾PLATZ　サンプル大学 看護学部 小論文ワークシート</a:t>
             </a:r>
           </a:p>
         </p:txBody>
@@ -19196,7 +19196,7 @@
                 <a:latin typeface="游ゴシック"/>
                 <a:ea typeface="游ゴシック"/>
               </a:rPr>
-              <a:t>C3進学アカデミー　サンプル大学 看護学部 小論文ワークシート</a:t>
+              <a:t>個人指導塾PLATZ　サンプル大学 看護学部 小論文ワークシート</a:t>
             </a:r>
           </a:p>
         </p:txBody>
@@ -20694,7 +20694,7 @@
                 <a:latin typeface="游ゴシック"/>
                 <a:ea typeface="游ゴシック"/>
               </a:rPr>
-              <a:t>C3進学アカデミー　サンプル大学 看護学部 小論文ワークシート</a:t>
+              <a:t>個人指導塾PLATZ　サンプル大学 看護学部 小論文ワークシート</a:t>
             </a:r>
           </a:p>
         </p:txBody>
@@ -21684,7 +21684,7 @@
                 <a:latin typeface="游ゴシック"/>
                 <a:ea typeface="游ゴシック"/>
               </a:rPr>
-              <a:t>C3進学アカデミー　サンプル大学 看護学部 小論文ワークシート</a:t>
+              <a:t>個人指導塾PLATZ　サンプル大学 看護学部 小論文ワークシート</a:t>
             </a:r>
           </a:p>
         </p:txBody>
@@ -22882,7 +22882,7 @@
                 <a:latin typeface="游ゴシック"/>
                 <a:ea typeface="游ゴシック"/>
               </a:rPr>
-              <a:t>C3進学アカデミー　サンプル大学 看護学部 小論文ワークシート</a:t>
+              <a:t>個人指導塾PLATZ　サンプル大学 看護学部 小論文ワークシート</a:t>
             </a:r>
           </a:p>
         </p:txBody>
@@ -23670,7 +23670,7 @@
                 <a:latin typeface="游ゴシック"/>
                 <a:ea typeface="游ゴシック"/>
               </a:rPr>
-              <a:t>C3進学アカデミー　サンプル大学 看護学部 小論文ワークシート</a:t>
+              <a:t>個人指導塾PLATZ　サンプル大学 看護学部 小論文ワークシート</a:t>
             </a:r>
           </a:p>
         </p:txBody>
@@ -24958,7 +24958,7 @@
                 <a:latin typeface="游ゴシック"/>
                 <a:ea typeface="游ゴシック"/>
               </a:rPr>
-              <a:t>C3進学アカデミー　サンプル大学 看護学部 小論文ワークシート</a:t>
+              <a:t>個人指導塾PLATZ　サンプル大学 看護学部 小論文ワークシート</a:t>
             </a:r>
           </a:p>
         </p:txBody>
@@ -26852,7 +26852,7 @@
                 <a:latin typeface="游ゴシック"/>
                 <a:ea typeface="游ゴシック"/>
               </a:rPr>
-              <a:t>C3進学アカデミー　サンプル大学 看護学部 小論文ワークシート</a:t>
+              <a:t>個人指導塾PLATZ　サンプル大学 看護学部 小論文ワークシート</a:t>
             </a:r>
           </a:p>
         </p:txBody>

</xml_diff>